<commit_message>
deck: real Gemma captions on slide 6, harness contract + live repo URL on slide 8
</commit_message>
<xml_diff>
--- a/submission/TextSink_Track2.pptx
+++ b/submission/TextSink_Track2.pptx
@@ -4225,7 +4225,7 @@
                 <a:ea typeface="Calibri" pitchFamily="34" charset="-122"/>
                 <a:cs typeface="Calibri" pitchFamily="34" charset="-120"/>
               </a:rPr>
-              <a:t>red circle + blue square on white; on-screen text 'OPEN 24/7' </a:t>
+              <a:t>official judge clip: an orange tabby kitten walks toward the camera through sunlit foliage </a:t>
             </a:r>
             <a:endParaRPr lang="en-US" sz="1400" dirty="0"/>
           </a:p>
@@ -4264,6 +4264,10 @@
             </a:outerShdw>
           </a:effectLst>
         </p:spPr>
+        <p:txBody>
+          <a:bodyPr/>
+          <a:p/>
+        </p:txBody>
       </p:sp>
       <p:sp>
         <p:nvSpPr>
@@ -4337,7 +4341,7 @@
                 <a:ea typeface="Calibri" pitchFamily="34" charset="-122"/>
                 <a:cs typeface="Calibri" pitchFamily="34" charset="-120"/>
               </a:rPr>
-              <a:t>"A red circle and a blue square on a plain white background, alongside the text OPEN 24/7."</a:t>
+              <a:t>"An orange tabby kitten walks forward through the foliage toward the camera in a wooded area."</a:t>
             </a:r>
             <a:endParaRPr lang="en-US" sz="1550" dirty="0"/>
           </a:p>
@@ -4376,6 +4380,10 @@
             </a:outerShdw>
           </a:effectLst>
         </p:spPr>
+        <p:txBody>
+          <a:bodyPr/>
+          <a:p/>
+        </p:txBody>
       </p:sp>
       <p:sp>
         <p:nvSpPr>
@@ -4449,7 +4457,7 @@
                 <a:ea typeface="Calibri" pitchFamily="34" charset="-122"/>
                 <a:cs typeface="Calibri" pitchFamily="34" charset="-120"/>
               </a:rPr>
-              <a:t>"Groundbreaking shapes and a commitment to being open all the time. Truly a revolution in graphic design."</a:t>
+              <a:t>"A fierce predator emerges from the brush, clearly ready to conquer the entire forest one tiny, uncoordinated step at a time."</a:t>
             </a:r>
             <a:endParaRPr lang="en-US" sz="1550" dirty="0"/>
           </a:p>
@@ -4488,6 +4496,10 @@
             </a:outerShdw>
           </a:effectLst>
         </p:spPr>
+        <p:txBody>
+          <a:bodyPr/>
+          <a:p/>
+        </p:txBody>
       </p:sp>
       <p:sp>
         <p:nvSpPr>
@@ -4561,7 +4573,7 @@
                 <a:ea typeface="Calibri" pitchFamily="34" charset="-122"/>
                 <a:cs typeface="Calibri" pitchFamily="34" charset="-120"/>
               </a:rPr>
-              <a:t>"The UI is finally live, but someone forgot the dark-mode toggle. At least the uptime is solid."</a:t>
+              <a:t>"The latest AI agent successfully navigating its first training environment. It’s small, but the feature set is looking promising."</a:t>
             </a:r>
             <a:endParaRPr lang="en-US" sz="1550" dirty="0"/>
           </a:p>
@@ -4600,6 +4612,10 @@
             </a:outerShdw>
           </a:effectLst>
         </p:spPr>
+        <p:txBody>
+          <a:bodyPr/>
+          <a:p/>
+        </p:txBody>
       </p:sp>
       <p:sp>
         <p:nvSpPr>
@@ -4673,7 +4689,7 @@
                 <a:ea typeface="Calibri" pitchFamily="34" charset="-122"/>
                 <a:cs typeface="Calibri" pitchFamily="34" charset="-120"/>
               </a:rPr>
-              <a:t>"The red circle and blue square are clearly working the night shift — they are open 24/7."</a:t>
+              <a:t>"A tiny orange explorer makes a grand entrance, bravely navigating the treacherous jungle of backyard leaves."</a:t>
             </a:r>
             <a:endParaRPr lang="en-US" sz="1550" dirty="0"/>
           </a:p>
@@ -5351,6 +5367,10 @@
             </a:outerShdw>
           </a:effectLst>
         </p:spPr>
+        <p:txBody>
+          <a:bodyPr/>
+          <a:p/>
+        </p:txBody>
       </p:sp>
       <p:sp>
         <p:nvSpPr>
@@ -5458,7 +5478,7 @@
                 <a:ea typeface="Courier New" pitchFamily="34" charset="-122"/>
                 <a:cs typeface="Courier New" pitchFamily="34" charset="-120"/>
               </a:rPr>
-              <a:t>  -v $PWD/videos:/data/in \</a:t>
+              <a:t>  -v $PWD/input:/input:ro \</a:t>
             </a:r>
             <a:endParaRPr lang="en-US" sz="1250" dirty="0"/>
           </a:p>
@@ -5475,7 +5495,7 @@
                 <a:ea typeface="Courier New" pitchFamily="34" charset="-122"/>
                 <a:cs typeface="Courier New" pitchFamily="34" charset="-120"/>
               </a:rPr>
-              <a:t>  -v $PWD/out:/data/out \</a:t>
+              <a:t>  -v $PWD/out:/output \</a:t>
             </a:r>
             <a:endParaRPr lang="en-US" sz="1250" dirty="0"/>
           </a:p>
@@ -5492,7 +5512,7 @@
                 <a:ea typeface="Courier New" pitchFamily="34" charset="-122"/>
                 <a:cs typeface="Courier New" pitchFamily="34" charset="-120"/>
               </a:rPr>
-              <a:t>  cinetone</a:t>
+              <a:t>  textsink</a:t>
             </a:r>
             <a:endParaRPr lang="en-US" sz="1250" dirty="0"/>
           </a:p>
@@ -5570,7 +5590,7 @@
                 <a:ea typeface="Courier New" pitchFamily="34" charset="-122"/>
                 <a:cs typeface="Courier New" pitchFamily="34" charset="-120"/>
               </a:rPr>
-              <a:t>github.com/&lt;your-handle&gt;/amd-track2-captioner</a:t>
+              <a:t>github.com/banksythequantLab/textsink</a:t>
             </a:r>
             <a:endParaRPr lang="en-US" sz="1500" dirty="0"/>
           </a:p>

</xml_diff>